<commit_message>
fix(G2-R04): align formal document formatting and captions
</commit_message>
<xml_diff>
--- a/docs/deliverables/figures/08-图1-1-需求双镜像与追踪关系.pptx
+++ b/docs/deliverables/figures/08-图1-1-需求双镜像与追踪关系.pptx
@@ -3393,6 +3393,9 @@
               <a:pPr algn="ctr"/>
               <a:r>
                 <a:rPr lang="zh-CN" altLang="en-US" sz="1600">
+                  <a:solidFill>
+                    <a:srgbClr val="333333"/>
+                  </a:solidFill>
                   <a:latin typeface="宋体" panose="02010600030101010101" pitchFamily="2" charset="-122"/>
                 </a:rPr>
                 <a:t>受控需求源</a:t>
@@ -3452,6 +3455,9 @@
               <a:pPr algn="ctr"/>
               <a:r>
                 <a:rPr lang="en-US" altLang="zh-CN" sz="1600">
+                  <a:solidFill>
+                    <a:srgbClr val="333333"/>
+                  </a:solidFill>
                   <a:latin typeface="宋体" panose="02010600030101010101" pitchFamily="2" charset="-122"/>
                 </a:rPr>
                 <a:t>SRS</a:t>
@@ -3556,12 +3562,18 @@
               <a:pPr algn="ctr"/>
               <a:r>
                 <a:rPr lang="zh-CN" altLang="en-US" sz="1600">
+                  <a:solidFill>
+                    <a:srgbClr val="333333"/>
+                  </a:solidFill>
                   <a:latin typeface="宋体" panose="02010600030101010101" pitchFamily="2" charset="-122"/>
                 </a:rPr>
                 <a:t>机器可读 </a:t>
               </a:r>
               <a:r>
                 <a:rPr lang="en-US" altLang="zh-CN" sz="1600">
+                  <a:solidFill>
+                    <a:srgbClr val="333333"/>
+                  </a:solidFill>
                   <a:latin typeface="宋体" panose="02010600030101010101" pitchFamily="2" charset="-122"/>
                 </a:rPr>
                 <a:t>spec</a:t>
@@ -3666,6 +3678,9 @@
               <a:pPr algn="ctr"/>
               <a:r>
                 <a:rPr lang="en-US" altLang="zh-CN" sz="1600">
+                  <a:solidFill>
+                    <a:srgbClr val="333333"/>
+                  </a:solidFill>
                   <a:latin typeface="宋体" panose="02010600030101010101" pitchFamily="2" charset="-122"/>
                 </a:rPr>
                 <a:t>RTM</a:t>
@@ -3770,18 +3785,27 @@
               <a:pPr algn="ctr"/>
               <a:r>
                 <a:rPr lang="zh-CN" altLang="en-US" sz="1600">
+                  <a:solidFill>
+                    <a:srgbClr val="333333"/>
+                  </a:solidFill>
                   <a:latin typeface="宋体" panose="02010600030101010101" pitchFamily="2" charset="-122"/>
                 </a:rPr>
                 <a:t>设计</a:t>
               </a:r>
               <a:r>
                 <a:rPr lang="en-US" altLang="zh-CN" sz="1600">
+                  <a:solidFill>
+                    <a:srgbClr val="333333"/>
+                  </a:solidFill>
                   <a:latin typeface="宋体" panose="02010600030101010101" pitchFamily="2" charset="-122"/>
                 </a:rPr>
                 <a:t>/</a:t>
               </a:r>
               <a:r>
                 <a:rPr lang="zh-CN" altLang="en-US" sz="1600">
+                  <a:solidFill>
+                    <a:srgbClr val="333333"/>
+                  </a:solidFill>
                   <a:latin typeface="宋体" panose="02010600030101010101" pitchFamily="2" charset="-122"/>
                 </a:rPr>
                 <a:t>测试证据</a:t>

</xml_diff>